<commit_message>
Apply independent audit revisions
</commit_message>
<xml_diff>
--- a/presentation/lectionary_design_layer_deck.pptx
+++ b/presentation/lectionary_design_layer_deck.pptx
@@ -4546,7 +4546,7 @@
               </a:defRPr>
             </a:pPr>
             <a:r>
-              <a:t>2657</a:t>
+              <a:t>2658</a:t>
             </a:r>
           </a:p>
         </p:txBody>
@@ -4663,7 +4663,7 @@
               </a:defRPr>
             </a:pPr>
             <a:r>
-              <a:t>66378</a:t>
+              <a:t>66381</a:t>
             </a:r>
           </a:p>
         </p:txBody>
@@ -5616,7 +5616,7 @@
               </a:defRPr>
             </a:pPr>
             <a:r>
-              <a:t>445</a:t>
+              <a:t>446</a:t>
             </a:r>
           </a:p>
         </p:txBody>
@@ -5733,7 +5733,7 @@
               </a:defRPr>
             </a:pPr>
             <a:r>
-              <a:t>445</a:t>
+              <a:t>446</a:t>
             </a:r>
           </a:p>
         </p:txBody>
@@ -5850,7 +5850,7 @@
               </a:defRPr>
             </a:pPr>
             <a:r>
-              <a:t>419</a:t>
+              <a:t>420</a:t>
             </a:r>
           </a:p>
         </p:txBody>
@@ -6218,7 +6218,7 @@
               </a:defRPr>
             </a:pPr>
             <a:r>
-              <a:t>7</a:t>
+              <a:t>11</a:t>
             </a:r>
           </a:p>
         </p:txBody>
@@ -6452,7 +6452,7 @@
               </a:defRPr>
             </a:pPr>
             <a:r>
-              <a:t>152</a:t>
+              <a:t>149</a:t>
             </a:r>
           </a:p>
         </p:txBody>
@@ -7090,7 +7090,7 @@
               </a:defRPr>
             </a:pPr>
             <a:r>
-              <a:t>4688</a:t>
+              <a:t>789</a:t>
             </a:r>
           </a:p>
         </p:txBody>
@@ -7126,7 +7126,7 @@
               </a:defRPr>
             </a:pPr>
             <a:r>
-              <a:t>medium confidence</a:t>
+              <a:t>explicit basis</a:t>
             </a:r>
           </a:p>
         </p:txBody>
@@ -7243,7 +7243,7 @@
               </a:defRPr>
             </a:pPr>
             <a:r>
-              <a:t>All bridge rows are collection-type links. Repeated slots are source-row or variant catalog entries, not a resolved service schedule.</a:t>
+              <a:t>Outside-69 rows remain collection-type and medium confidence. Repeated slots are source-row or variant catalog entries, not a resolved service schedule.</a:t>
             </a:r>
           </a:p>
         </p:txBody>

</xml_diff>